<commit_message>
Exporte nach Probe-Durchgang aktualisiert
Folien korrigiert: Kernerstr 14 hat drei Einheitentypen,
Weg zum Demo-Objekt über den Typ-Filter, Hinweis zu w: majority mit
Lesen vom Secondary, „Code zeigen“ bei der Transaktion, mongo1 nach
15–20 s wieder Primary.

Co-Authored-By: Claude Opus 5.5 <noreply@anthropic.com>
</commit_message>
<xml_diff>
--- a/Mietverwaltung mit MongoDB und Redis.pptx
+++ b/Mietverwaltung mit MongoDB und Redis.pptx
@@ -814,7 +814,7 @@
           <a:p>
             <a:r>
               <a:rPr lang="en-US" dirty="0"/>
-              <a:t>ca. 3 Minuten, in den Browser wechseln. 1) Übersicht: oben das Badge zeigen, aus Redis oder MongoDB, mit Millisekunden. Statusleiste oben rechts erklären, sie wird beim Failover wichtig. 2) Objekte: Wohn- und Geschäftshaus öffnen (in der Übersicht unter "meiste offene Vorgänge"). Einheiten-Tabelle: Gewerbe, Wohnungen, Garagen mit unterschiedlichen Merkmalen. 3) Rechts den Vertrag auf "Dokument" umschalten: genau dieses Dokument kommt mit einem Zugriff. 4) Markt: ein Inserat aufklappen, gestrichelte Chips = Feld fehlt. Spur-Zeilen unter den Bereichen zeigen jeweils die Abfrage.</a:t>
+              <a:t>ca. 3 Minuten, in den Browser wechseln (Tab 1, Zoom 125 %, Spur an). 1) Übersicht: Statusleiste oben rechts zeigen, sie wird beim Failover wichtig. "Neu berechnen" klicken (aus MongoDB, ca. 200 ms), dann Seite neu laden (aus Redis, unter 1 ms). Spur-Zeile unter "Bestandsmiete und Angebotsmiete je Kreis" zeigen: vier Collections, $lookup, $facet, $median. 2) Objekte: Typ-Filter "Wohn- und Geschäftshaus". In der Zeile WGH Kernerstr 14 die Quadrate (eingebettete Einheiten) und den Strich beim Baujahr (Feld fehlt im echten Inserat) zeigen. 3) WGH Kernerstr 14 anklicken: Arztpraxis L01, acht Wohnungen, zwei Garagen, also drei der vier Einheitentypen in einem Dokument. 4) Einheit W05 anklicken: Indexmiete mit sechs Anpassungen, Übergabeprotokoll, Marktvergleich. Umschalter "Dokument": genau dieses Dokument liefert ein Lesezugriff, relational fünf Tabellen und vier Joins; mieter_namen als bewusste Kopie zeigen. 5) Nur bei Zeit (vor 6:30): Markt, ein Inserat aufklappen, gestrichelte Chips = Feld fehlt.</a:t>
             </a:r>
           </a:p>
         </p:txBody>
@@ -901,7 +901,7 @@
           <a:p>
             <a:r>
               <a:rPr lang="en-US" dirty="0"/>
-              <a:t>ca. 5 Minuten. Reihenfolge nach Wirkung, nicht nach Nummer. 1) FAILOVER ZUERST, weil es 10 bis 15 Sekunden dauert: "Primary abschalten" klicken, währenddessen erklären: kill wie ein Absturz, die anderen merken es nach 10 s Herzschlag-Timeout und wählen neu. Statusleiste oben zeigt den Wechsel. Ergebnis vorlesen: neuer Primary nach ca. 10 s, Schreiben geht ohne App-Neustart weiter. 2) KONSISTENZ: erst w:majority + primary (0 veraltet), dann w:1 + secondary (fast alle veraltet). Das ist CAP zum Anfassen. 3) CACHE: zweimal messen, dann Invalidierung aus und "Schaden anlegen, neu lesen": Dashboard zeigt veraltete Zahl. Danach Invalidierung wieder an! 4) TRANSAKTION mit Abbruch: Schritte rot durchgestrichen, nichts gespeichert. 5) Wenn Zeit: Index, Kopien, Schema. Am Ende "Knoten wieder starten" nicht vergessen.</a:t>
+              <a:t>ca. 5 Minuten. Reihenfolge nach Wirkung, nicht nach Nummer. 1) FAILOVER ZUERST: "Primary abschalten" klicken und erklären, während die Uhr läuft: kill wie ein Absturz, nach 10 s ohne Herzschlag wählen die anderen neu, Mehrheit 2 von 3, so lange keine Schreibzugriffe (CP). Ergebnis vorlesen: neuer Primary nach rund 10 s, Schreiben ohne App-Neustart. Jetzt NICHT "Knoten wieder starten". 2) KONSISTENZ: erst w: majority + primary (0 veraltet), dann w: 1 + secondary (fast alle veraltet). CAP zum Anfassen. majority + secondary nicht zeigen: Mit zwei Knoten kommt dort 0 heraus (Mehrheit = beide), mit drei Knoten rund 30 % veraltet. 3) CACHE: zweimal messen, dann Invalidierung aus und "Schaden anlegen, neu lesen": Dashboard zeigt 89 statt 90. Danach Invalidierung wieder an! 4) TRANSAKTION mit Abbruch: Schritte 1 bis 3 rot durchgestrichen, nichts gespeichert. Bei Zeit (vor 10:30) "Code zeigen": with_transaction und raise SimulierterFehler. 5) Wenn Zeit: Kopien (Häkchen aus, Nachname ändern). Index und Schema nur auf Nachfrage. 6) Am Ende "Knoten wieder starten", dann zu Folie 8; mongo1 ist nach ca. 15 bis 20 s wieder Primary.</a:t>
             </a:r>
           </a:p>
         </p:txBody>
@@ -5256,7 +5256,7 @@
                 <a:ea typeface="IBM Plex Sans" pitchFamily="34" charset="-122"/>
                 <a:cs typeface="IBM Plex Sans" pitchFamily="34" charset="-120"/>
               </a:rPr>
-              <a:t>Objekt: eingebettete Einheiten, vier Typen in einem Dokument</a:t>
+              <a:t>Objekt: eingebettete Einheiten, verschiedene Typen in einem Dokument</a:t>
             </a:r>
             <a:endParaRPr lang="en-US" sz="1800" dirty="0"/>
           </a:p>

</xml_diff>